<commit_message>
Corregir estilo de tabla (evita bandas del tema en PowerPoint) y agregar ZIP
</commit_message>
<xml_diff>
--- a/presentacion-4g/Concesiones_Viales_4G_Presentacion.pptx
+++ b/presentacion-4g/Concesiones_Viales_4G_Presentacion.pptx
@@ -9936,7 +9936,9 @@
         <a:graphic>
           <a:graphicData uri="http://schemas.openxmlformats.org/drawingml/2006/table">
             <a:tbl>
-              <a:tblPr firstRow="0" bandRow="0"/>
+              <a:tblPr firstRow="0" bandRow="0">
+                <a:tableStyleId>{2D5ABB26-0587-4C30-8999-92F81FD0307C}</a:tableStyleId>
+              </a:tblPr>
               <a:tblGrid>
                 <a:gridCol w="2788920"/>
                 <a:gridCol w="7903159"/>
@@ -13366,7 +13368,9 @@
         <a:graphic>
           <a:graphicData uri="http://schemas.openxmlformats.org/drawingml/2006/table">
             <a:tbl>
-              <a:tblPr firstRow="0" bandRow="0"/>
+              <a:tblPr firstRow="0" bandRow="0">
+                <a:tableStyleId>{2D5ABB26-0587-4C30-8999-92F81FD0307C}</a:tableStyleId>
+              </a:tblPr>
               <a:tblGrid>
                 <a:gridCol w="2331720"/>
                 <a:gridCol w="3886200"/>

</xml_diff>